<commit_message>
Enhance project presentation with professional styling and detailed steps
Co-authored-by: Junie <junie@jetbrains.com>
</commit_message>
<xml_diff>
--- a/presentation.pptx
+++ b/presentation.pptx
@@ -15,6 +15,10 @@
     <p:sldId id="263" r:id="rId14"/>
     <p:sldId id="264" r:id="rId15"/>
     <p:sldId id="265" r:id="rId16"/>
+    <p:sldId id="266" r:id="rId17"/>
+    <p:sldId id="267" r:id="rId18"/>
+    <p:sldId id="268" r:id="rId19"/>
+    <p:sldId id="269" r:id="rId20"/>
   </p:sldIdLst>
   <p:sldSz cx="9144000" cy="6858000" type="screen4x3"/>
   <p:notesSz cx="6858000" cy="9144000"/>
@@ -3112,6 +3116,13 @@
           <a:bodyPr/>
           <a:lstStyle/>
           <a:p>
+            <a:pPr>
+              <a:defRPr>
+                <a:solidFill>
+                  <a:srgbClr val="003366"/>
+                </a:solidFill>
+              </a:defRPr>
+            </a:pPr>
             <a:r>
               <a:t>Breast Cancer Diagnostic Assistant</a:t>
             </a:r>
@@ -3134,7 +3145,12 @@
           <a:lstStyle/>
           <a:p>
             <a:r>
-              <a:t>Clinical Tool for Breast Mass Classification using Machine Learning</a:t>
+              <a:t>Advanced Machine Learning for Clinical Decision Support</a:t>
+            </a:r>
+          </a:p>
+          <a:p>
+            <a:r>
+              <a:t>Dataset: Wisconsin Breast Cancer (Diagnostic)</a:t>
             </a:r>
           </a:p>
           <a:p>
@@ -3177,6 +3193,400 @@
           <a:bodyPr/>
           <a:lstStyle/>
           <a:p>
+            <a:pPr>
+              <a:defRPr b="1">
+                <a:solidFill>
+                  <a:srgbClr val="003366"/>
+                </a:solidFill>
+              </a:defRPr>
+            </a:pPr>
+            <a:r>
+              <a:t>Step 4: Model Selection &amp; Training</a:t>
+            </a:r>
+          </a:p>
+        </p:txBody>
+      </p:sp>
+      <p:sp>
+        <p:nvSpPr>
+          <p:cNvPr id="3" name="Content Placeholder 2"/>
+          <p:cNvSpPr>
+            <a:spLocks noGrp="1"/>
+          </p:cNvSpPr>
+          <p:nvPr>
+            <p:ph idx="1"/>
+          </p:nvPr>
+        </p:nvSpPr>
+        <p:spPr/>
+        <p:txBody>
+          <a:bodyPr/>
+          <a:lstStyle/>
+          <a:p>
+            <a:r>
+              <a:t>Multiple models were evaluated to find the most reliable classifier:</a:t>
+            </a:r>
+          </a:p>
+          <a:p>
+            <a:pPr>
+              <a:defRPr sz="1800"/>
+            </a:pPr>
+            <a:r>
+              <a:t>Logistic Regression: Baseline model with L2 regularization.</a:t>
+            </a:r>
+          </a:p>
+          <a:p>
+            <a:pPr>
+              <a:defRPr sz="1800"/>
+            </a:pPr>
+            <a:r>
+              <a:t>Random Forest: Ensemble of decision trees to capture non-linearities.</a:t>
+            </a:r>
+          </a:p>
+          <a:p>
+            <a:pPr>
+              <a:defRPr sz="1800"/>
+            </a:pPr>
+            <a:r>
+              <a:t>Soft Voting Ensemble: Combining both for robust predictions.</a:t>
+            </a:r>
+          </a:p>
+          <a:p>
+            <a:pPr>
+              <a:defRPr sz="1800"/>
+            </a:pPr>
+            <a:r>
+              <a:t>Optimization: Hyperparameter tuning via GridSearchCV.</a:t>
+            </a:r>
+          </a:p>
+        </p:txBody>
+      </p:sp>
+    </p:spTree>
+  </p:cSld>
+  <p:clrMapOvr>
+    <a:masterClrMapping/>
+  </p:clrMapOvr>
+</p:sld>
+</file>
+
+<file path=ppt/slides/slide11.xml><?xml version="1.0" encoding="utf-8"?>
+<p:sld xmlns:a="http://schemas.openxmlformats.org/drawingml/2006/main" xmlns:p="http://schemas.openxmlformats.org/presentationml/2006/main" xmlns:r="http://schemas.openxmlformats.org/officeDocument/2006/relationships">
+  <p:cSld>
+    <p:spTree>
+      <p:nvGrpSpPr>
+        <p:cNvPr id="1" name=""/>
+        <p:cNvGrpSpPr/>
+        <p:nvPr/>
+      </p:nvGrpSpPr>
+      <p:grpSpPr/>
+      <p:sp>
+        <p:nvSpPr>
+          <p:cNvPr id="2" name="Title 1"/>
+          <p:cNvSpPr>
+            <a:spLocks noGrp="1"/>
+          </p:cNvSpPr>
+          <p:nvPr>
+            <p:ph type="title"/>
+          </p:nvPr>
+        </p:nvSpPr>
+        <p:spPr/>
+        <p:txBody>
+          <a:bodyPr/>
+          <a:lstStyle/>
+          <a:p>
+            <a:pPr>
+              <a:defRPr b="1">
+                <a:solidFill>
+                  <a:srgbClr val="003366"/>
+                </a:solidFill>
+              </a:defRPr>
+            </a:pPr>
+            <a:r>
+              <a:t>Step 5: Performance Evaluation</a:t>
+            </a:r>
+          </a:p>
+        </p:txBody>
+      </p:sp>
+      <p:sp>
+        <p:nvSpPr>
+          <p:cNvPr id="3" name="Content Placeholder 2"/>
+          <p:cNvSpPr>
+            <a:spLocks noGrp="1"/>
+          </p:cNvSpPr>
+          <p:nvPr>
+            <p:ph idx="1"/>
+          </p:nvPr>
+        </p:nvSpPr>
+        <p:spPr/>
+        <p:txBody>
+          <a:bodyPr/>
+          <a:lstStyle/>
+          <a:p>
+            <a:r>
+              <a:t>Best Performing Model: Logistic Regression (C=1)</a:t>
+            </a:r>
+          </a:p>
+          <a:p>
+            <a:pPr lvl="1">
+              <a:defRPr sz="1800"/>
+            </a:pPr>
+            <a:r>
+              <a:t>Accuracy: 97.4%</a:t>
+            </a:r>
+          </a:p>
+          <a:p>
+            <a:pPr lvl="1">
+              <a:defRPr sz="1800"/>
+            </a:pPr>
+            <a:r>
+              <a:t>Precision: 97.2% (Minimizing False Positives)</a:t>
+            </a:r>
+          </a:p>
+          <a:p>
+            <a:pPr lvl="1">
+              <a:defRPr sz="1800"/>
+            </a:pPr>
+            <a:r>
+              <a:t>Recall: 98.6% (Minimizing False Negatives - CRITICAL)</a:t>
+            </a:r>
+          </a:p>
+          <a:p>
+            <a:pPr lvl="1">
+              <a:defRPr sz="1800"/>
+            </a:pPr>
+            <a:r>
+              <a:t>F1-Score: 0.98</a:t>
+            </a:r>
+          </a:p>
+        </p:txBody>
+      </p:sp>
+    </p:spTree>
+  </p:cSld>
+  <p:clrMapOvr>
+    <a:masterClrMapping/>
+  </p:clrMapOvr>
+</p:sld>
+</file>
+
+<file path=ppt/slides/slide12.xml><?xml version="1.0" encoding="utf-8"?>
+<p:sld xmlns:a="http://schemas.openxmlformats.org/drawingml/2006/main" xmlns:p="http://schemas.openxmlformats.org/presentationml/2006/main" xmlns:r="http://schemas.openxmlformats.org/officeDocument/2006/relationships">
+  <p:cSld>
+    <p:spTree>
+      <p:nvGrpSpPr>
+        <p:cNvPr id="1" name=""/>
+        <p:cNvGrpSpPr/>
+        <p:nvPr/>
+      </p:nvGrpSpPr>
+      <p:grpSpPr/>
+      <p:sp>
+        <p:nvSpPr>
+          <p:cNvPr id="2" name="Title 1"/>
+          <p:cNvSpPr>
+            <a:spLocks noGrp="1"/>
+          </p:cNvSpPr>
+          <p:nvPr>
+            <p:ph type="title"/>
+          </p:nvPr>
+        </p:nvSpPr>
+        <p:spPr/>
+        <p:txBody>
+          <a:bodyPr/>
+          <a:lstStyle/>
+          <a:p>
+            <a:pPr>
+              <a:defRPr b="1">
+                <a:solidFill>
+                  <a:srgbClr val="003366"/>
+                </a:solidFill>
+              </a:defRPr>
+            </a:pPr>
+            <a:r>
+              <a:t>Evaluation: Confusion Matrix</a:t>
+            </a:r>
+          </a:p>
+        </p:txBody>
+      </p:sp>
+      <p:pic>
+        <p:nvPicPr>
+          <p:cNvPr id="3" name="Picture 2" descr="cm_Logistic_Regression.png"/>
+          <p:cNvPicPr>
+            <a:picLocks noChangeAspect="1"/>
+          </p:cNvPicPr>
+          <p:nvPr/>
+        </p:nvPicPr>
+        <p:blipFill>
+          <a:blip r:embed="rId2"/>
+          <a:stretch>
+            <a:fillRect/>
+          </a:stretch>
+        </p:blipFill>
+        <p:spPr>
+          <a:xfrm>
+            <a:off x="1371600" y="1371600"/>
+            <a:ext cx="6858000" cy="4572000"/>
+          </a:xfrm>
+          <a:prstGeom prst="rect">
+            <a:avLst/>
+          </a:prstGeom>
+        </p:spPr>
+      </p:pic>
+      <p:sp>
+        <p:nvSpPr>
+          <p:cNvPr id="4" name="TextBox 3"/>
+          <p:cNvSpPr txBox="1"/>
+          <p:nvPr/>
+        </p:nvSpPr>
+        <p:spPr>
+          <a:xfrm>
+            <a:off x="914400" y="5943600"/>
+            <a:ext cx="7315200" cy="914400"/>
+          </a:xfrm>
+          <a:prstGeom prst="rect">
+            <a:avLst/>
+          </a:prstGeom>
+          <a:noFill/>
+        </p:spPr>
+        <p:txBody>
+          <a:bodyPr wrap="none">
+            <a:spAutoFit/>
+          </a:bodyPr>
+          <a:lstStyle/>
+          <a:p>
+            <a:r>
+              <a:t>Interpretation: High recall ensures very few malignant cases are missed, which is vital in medical diagnostics.</a:t>
+            </a:r>
+          </a:p>
+        </p:txBody>
+      </p:sp>
+    </p:spTree>
+  </p:cSld>
+  <p:clrMapOvr>
+    <a:masterClrMapping/>
+  </p:clrMapOvr>
+</p:sld>
+</file>
+
+<file path=ppt/slides/slide13.xml><?xml version="1.0" encoding="utf-8"?>
+<p:sld xmlns:a="http://schemas.openxmlformats.org/drawingml/2006/main" xmlns:p="http://schemas.openxmlformats.org/presentationml/2006/main" xmlns:r="http://schemas.openxmlformats.org/officeDocument/2006/relationships">
+  <p:cSld>
+    <p:spTree>
+      <p:nvGrpSpPr>
+        <p:cNvPr id="1" name=""/>
+        <p:cNvGrpSpPr/>
+        <p:nvPr/>
+      </p:nvGrpSpPr>
+      <p:grpSpPr/>
+      <p:sp>
+        <p:nvSpPr>
+          <p:cNvPr id="2" name="Title 1"/>
+          <p:cNvSpPr>
+            <a:spLocks noGrp="1"/>
+          </p:cNvSpPr>
+          <p:nvPr>
+            <p:ph type="title"/>
+          </p:nvPr>
+        </p:nvSpPr>
+        <p:spPr/>
+        <p:txBody>
+          <a:bodyPr/>
+          <a:lstStyle/>
+          <a:p>
+            <a:pPr>
+              <a:defRPr b="1">
+                <a:solidFill>
+                  <a:srgbClr val="003366"/>
+                </a:solidFill>
+              </a:defRPr>
+            </a:pPr>
+            <a:r>
+              <a:t>Step 6: Clinical Deployment</a:t>
+            </a:r>
+          </a:p>
+        </p:txBody>
+      </p:sp>
+      <p:sp>
+        <p:nvSpPr>
+          <p:cNvPr id="3" name="Content Placeholder 2"/>
+          <p:cNvSpPr>
+            <a:spLocks noGrp="1"/>
+          </p:cNvSpPr>
+          <p:nvPr>
+            <p:ph idx="1"/>
+          </p:nvPr>
+        </p:nvSpPr>
+        <p:spPr/>
+        <p:txBody>
+          <a:bodyPr/>
+          <a:lstStyle/>
+          <a:p>
+            <a:r>
+              <a:t>The model is deployed as an interactive web application.</a:t>
+            </a:r>
+          </a:p>
+          <a:p>
+            <a:pPr>
+              <a:defRPr sz="1800"/>
+            </a:pPr>
+            <a:r>
+              <a:t>Features: Real-time prediction and diagnostic confidence scores.</a:t>
+            </a:r>
+          </a:p>
+          <a:p>
+            <a:pPr>
+              <a:defRPr sz="1800"/>
+            </a:pPr>
+            <a:r>
+              <a:t>Ease of Use: Interactive sliders for all 30 diagnostic metrics.</a:t>
+            </a:r>
+          </a:p>
+          <a:p>
+            <a:pPr>
+              <a:defRPr sz="1800"/>
+            </a:pPr>
+            <a:r>
+              <a:t>Transparency: Integration of performance metrics for clinical trust.</a:t>
+            </a:r>
+          </a:p>
+        </p:txBody>
+      </p:sp>
+    </p:spTree>
+  </p:cSld>
+  <p:clrMapOvr>
+    <a:masterClrMapping/>
+  </p:clrMapOvr>
+</p:sld>
+</file>
+
+<file path=ppt/slides/slide14.xml><?xml version="1.0" encoding="utf-8"?>
+<p:sld xmlns:a="http://schemas.openxmlformats.org/drawingml/2006/main" xmlns:p="http://schemas.openxmlformats.org/presentationml/2006/main" xmlns:r="http://schemas.openxmlformats.org/officeDocument/2006/relationships">
+  <p:cSld>
+    <p:spTree>
+      <p:nvGrpSpPr>
+        <p:cNvPr id="1" name=""/>
+        <p:cNvGrpSpPr/>
+        <p:nvPr/>
+      </p:nvGrpSpPr>
+      <p:grpSpPr/>
+      <p:sp>
+        <p:nvSpPr>
+          <p:cNvPr id="2" name="Title 1"/>
+          <p:cNvSpPr>
+            <a:spLocks noGrp="1"/>
+          </p:cNvSpPr>
+          <p:nvPr>
+            <p:ph type="title"/>
+          </p:nvPr>
+        </p:nvSpPr>
+        <p:spPr/>
+        <p:txBody>
+          <a:bodyPr/>
+          <a:lstStyle/>
+          <a:p>
+            <a:pPr>
+              <a:defRPr b="1">
+                <a:solidFill>
+                  <a:srgbClr val="003366"/>
+                </a:solidFill>
+              </a:defRPr>
+            </a:pPr>
             <a:r>
               <a:t>Conclusion</a:t>
             </a:r>
@@ -3199,17 +3609,31 @@
           <a:lstStyle/>
           <a:p>
             <a:r>
-              <a:t>- Successfully developed a high-precision diagnostic tool.</a:t>
-            </a:r>
-          </a:p>
-          <a:p>
-            <a:r>
-              <a:t>- Deployment-ready on Streamlit Community Cloud.</a:t>
-            </a:r>
-          </a:p>
-          <a:p>
-            <a:r>
-              <a:t>- Future Work: Integrate with electronic health records (EHR) and expand dataset.</a:t>
+              <a:t>Project Summary:</a:t>
+            </a:r>
+          </a:p>
+          <a:p>
+            <a:pPr>
+              <a:defRPr sz="1800"/>
+            </a:pPr>
+            <a:r>
+              <a:t>Achieved 97.4% accuracy in classification.</a:t>
+            </a:r>
+          </a:p>
+          <a:p>
+            <a:pPr>
+              <a:defRPr sz="1800"/>
+            </a:pPr>
+            <a:r>
+              <a:t>Developed a fully functional, deployment-ready diagnostic tool.</a:t>
+            </a:r>
+          </a:p>
+          <a:p>
+            <a:pPr>
+              <a:defRPr sz="1800"/>
+            </a:pPr>
+            <a:r>
+              <a:t>Established a robust ML pipeline from data to deployment.</a:t>
             </a:r>
           </a:p>
         </p:txBody>
@@ -3247,8 +3671,15 @@
           <a:bodyPr/>
           <a:lstStyle/>
           <a:p>
-            <a:r>
-              <a:t>Project Overview</a:t>
+            <a:pPr>
+              <a:defRPr b="1">
+                <a:solidFill>
+                  <a:srgbClr val="003366"/>
+                </a:solidFill>
+              </a:defRPr>
+            </a:pPr>
+            <a:r>
+              <a:t>Presentation Outline</a:t>
             </a:r>
           </a:p>
         </p:txBody>
@@ -3269,22 +3700,55 @@
           <a:lstStyle/>
           <a:p>
             <a:r>
-              <a:t>- Objective: Classify tumors as Benign or Malignant.</a:t>
-            </a:r>
-          </a:p>
-          <a:p>
-            <a:r>
-              <a:t>- Dataset: Wisconsin Breast Cancer (Diagnostic).</a:t>
-            </a:r>
-          </a:p>
-          <a:p>
-            <a:r>
-              <a:t>- Features: 30 clinical features (Mean, Standard Error, Worst measurements).</a:t>
-            </a:r>
-          </a:p>
-          <a:p>
-            <a:r>
-              <a:t>- Technology Stack: Python, Scikit-Learn, Streamlit, Pandas, Joblib.</a:t>
+              <a:t>1. Problem Definition &amp; Dataset</a:t>
+            </a:r>
+          </a:p>
+          <a:p>
+            <a:pPr>
+              <a:defRPr sz="1800"/>
+            </a:pPr>
+            <a:r>
+              <a:t>2. Exploratory Data Analysis (EDA)</a:t>
+            </a:r>
+          </a:p>
+          <a:p>
+            <a:pPr>
+              <a:defRPr sz="1800"/>
+            </a:pPr>
+            <a:r>
+              <a:t>3. Data Preprocessing &amp; Pipeline</a:t>
+            </a:r>
+          </a:p>
+          <a:p>
+            <a:pPr>
+              <a:defRPr sz="1800"/>
+            </a:pPr>
+            <a:r>
+              <a:t>4. Model Selection &amp; Training</a:t>
+            </a:r>
+          </a:p>
+          <a:p>
+            <a:pPr>
+              <a:defRPr sz="1800"/>
+            </a:pPr>
+            <a:r>
+              <a:t>5. Performance Evaluation</a:t>
+            </a:r>
+          </a:p>
+          <a:p>
+            <a:pPr>
+              <a:defRPr sz="1800"/>
+            </a:pPr>
+            <a:r>
+              <a:t>6. Clinical Application (Streamlit)</a:t>
+            </a:r>
+          </a:p>
+          <a:p>
+            <a:pPr>
+              <a:defRPr sz="1800"/>
+            </a:pPr>
+            <a:r>
+              <a:t>7. Conclusion &amp; Future Scope</a:t>
             </a:r>
           </a:p>
         </p:txBody>
@@ -3322,8 +3786,205 @@
           <a:bodyPr/>
           <a:lstStyle/>
           <a:p>
-            <a:r>
-              <a:t>EDA: Feature Distributions</a:t>
+            <a:pPr>
+              <a:defRPr b="1">
+                <a:solidFill>
+                  <a:srgbClr val="003366"/>
+                </a:solidFill>
+              </a:defRPr>
+            </a:pPr>
+            <a:r>
+              <a:t>Step 1: Problem Definition</a:t>
+            </a:r>
+          </a:p>
+        </p:txBody>
+      </p:sp>
+      <p:sp>
+        <p:nvSpPr>
+          <p:cNvPr id="3" name="Content Placeholder 2"/>
+          <p:cNvSpPr>
+            <a:spLocks noGrp="1"/>
+          </p:cNvSpPr>
+          <p:nvPr>
+            <p:ph idx="1"/>
+          </p:nvPr>
+        </p:nvSpPr>
+        <p:spPr/>
+        <p:txBody>
+          <a:bodyPr/>
+          <a:lstStyle/>
+          <a:p>
+            <a:r>
+              <a:t>Objective: Early and accurate detection of breast cancer.</a:t>
+            </a:r>
+          </a:p>
+          <a:p>
+            <a:pPr>
+              <a:defRPr sz="1800"/>
+            </a:pPr>
+            <a:r>
+              <a:t>Clinical Significance: Breast cancer is the most common cancer among women globally.</a:t>
+            </a:r>
+          </a:p>
+          <a:p>
+            <a:pPr>
+              <a:defRPr sz="1800"/>
+            </a:pPr>
+            <a:r>
+              <a:t>Machine Learning Goal: Binary classification (Malignant vs. Benign).</a:t>
+            </a:r>
+          </a:p>
+          <a:p>
+            <a:pPr>
+              <a:defRPr sz="1800"/>
+            </a:pPr>
+            <a:r>
+              <a:t>Target Audience: Clinicians and healthcare providers.</a:t>
+            </a:r>
+          </a:p>
+        </p:txBody>
+      </p:sp>
+    </p:spTree>
+  </p:cSld>
+  <p:clrMapOvr>
+    <a:masterClrMapping/>
+  </p:clrMapOvr>
+</p:sld>
+</file>
+
+<file path=ppt/slides/slide4.xml><?xml version="1.0" encoding="utf-8"?>
+<p:sld xmlns:a="http://schemas.openxmlformats.org/drawingml/2006/main" xmlns:p="http://schemas.openxmlformats.org/presentationml/2006/main" xmlns:r="http://schemas.openxmlformats.org/officeDocument/2006/relationships">
+  <p:cSld>
+    <p:spTree>
+      <p:nvGrpSpPr>
+        <p:cNvPr id="1" name=""/>
+        <p:cNvGrpSpPr/>
+        <p:nvPr/>
+      </p:nvGrpSpPr>
+      <p:grpSpPr/>
+      <p:sp>
+        <p:nvSpPr>
+          <p:cNvPr id="2" name="Title 1"/>
+          <p:cNvSpPr>
+            <a:spLocks noGrp="1"/>
+          </p:cNvSpPr>
+          <p:nvPr>
+            <p:ph type="title"/>
+          </p:nvPr>
+        </p:nvSpPr>
+        <p:spPr/>
+        <p:txBody>
+          <a:bodyPr/>
+          <a:lstStyle/>
+          <a:p>
+            <a:pPr>
+              <a:defRPr b="1">
+                <a:solidFill>
+                  <a:srgbClr val="003366"/>
+                </a:solidFill>
+              </a:defRPr>
+            </a:pPr>
+            <a:r>
+              <a:t>Dataset: Wisconsin Breast Cancer</a:t>
+            </a:r>
+          </a:p>
+        </p:txBody>
+      </p:sp>
+      <p:sp>
+        <p:nvSpPr>
+          <p:cNvPr id="3" name="Content Placeholder 2"/>
+          <p:cNvSpPr>
+            <a:spLocks noGrp="1"/>
+          </p:cNvSpPr>
+          <p:nvPr>
+            <p:ph idx="1"/>
+          </p:nvPr>
+        </p:nvSpPr>
+        <p:spPr/>
+        <p:txBody>
+          <a:bodyPr/>
+          <a:lstStyle/>
+          <a:p>
+            <a:r>
+              <a:t>Source: UCI Machine Learning Repository</a:t>
+            </a:r>
+          </a:p>
+          <a:p>
+            <a:pPr>
+              <a:defRPr sz="1800"/>
+            </a:pPr>
+            <a:r>
+              <a:t>Total Instances: 569 patients</a:t>
+            </a:r>
+          </a:p>
+          <a:p>
+            <a:pPr>
+              <a:defRPr sz="1800"/>
+            </a:pPr>
+            <a:r>
+              <a:t>Total Features: 30 numeric diagnostic features</a:t>
+            </a:r>
+          </a:p>
+          <a:p>
+            <a:pPr>
+              <a:defRPr sz="1800"/>
+            </a:pPr>
+            <a:r>
+              <a:t>Feature Categories: Mean, Standard Error, and 'Worst' measurements of cell nuclei.</a:t>
+            </a:r>
+          </a:p>
+          <a:p>
+            <a:pPr>
+              <a:defRPr sz="1800"/>
+            </a:pPr>
+            <a:r>
+              <a:t>Class Distribution: 212 Malignant, 357 Benign.</a:t>
+            </a:r>
+          </a:p>
+        </p:txBody>
+      </p:sp>
+    </p:spTree>
+  </p:cSld>
+  <p:clrMapOvr>
+    <a:masterClrMapping/>
+  </p:clrMapOvr>
+</p:sld>
+</file>
+
+<file path=ppt/slides/slide5.xml><?xml version="1.0" encoding="utf-8"?>
+<p:sld xmlns:a="http://schemas.openxmlformats.org/drawingml/2006/main" xmlns:p="http://schemas.openxmlformats.org/presentationml/2006/main" xmlns:r="http://schemas.openxmlformats.org/officeDocument/2006/relationships">
+  <p:cSld>
+    <p:spTree>
+      <p:nvGrpSpPr>
+        <p:cNvPr id="1" name=""/>
+        <p:cNvGrpSpPr/>
+        <p:nvPr/>
+      </p:nvGrpSpPr>
+      <p:grpSpPr/>
+      <p:sp>
+        <p:nvSpPr>
+          <p:cNvPr id="2" name="Title 1"/>
+          <p:cNvSpPr>
+            <a:spLocks noGrp="1"/>
+          </p:cNvSpPr>
+          <p:nvPr>
+            <p:ph type="title"/>
+          </p:nvPr>
+        </p:nvSpPr>
+        <p:spPr/>
+        <p:txBody>
+          <a:bodyPr/>
+          <a:lstStyle/>
+          <a:p>
+            <a:pPr>
+              <a:defRPr b="1">
+                <a:solidFill>
+                  <a:srgbClr val="003366"/>
+                </a:solidFill>
+              </a:defRPr>
+            </a:pPr>
+            <a:r>
+              <a:t>Step 2: EDA - Feature Distributions</a:t>
             </a:r>
           </a:p>
         </p:txBody>
@@ -3352,6 +4013,34 @@
           </a:prstGeom>
         </p:spPr>
       </p:pic>
+      <p:sp>
+        <p:nvSpPr>
+          <p:cNvPr id="4" name="TextBox 3"/>
+          <p:cNvSpPr txBox="1"/>
+          <p:nvPr/>
+        </p:nvSpPr>
+        <p:spPr>
+          <a:xfrm>
+            <a:off x="914400" y="5943600"/>
+            <a:ext cx="7315200" cy="914400"/>
+          </a:xfrm>
+          <a:prstGeom prst="rect">
+            <a:avLst/>
+          </a:prstGeom>
+          <a:noFill/>
+        </p:spPr>
+        <p:txBody>
+          <a:bodyPr wrap="none">
+            <a:spAutoFit/>
+          </a:bodyPr>
+          <a:lstStyle/>
+          <a:p>
+            <a:r>
+              <a:t>Analysis: Most features exhibit normal or log-normal distributions. Scaling is required due to varying magnitudes.</a:t>
+            </a:r>
+          </a:p>
+        </p:txBody>
+      </p:sp>
     </p:spTree>
   </p:cSld>
   <p:clrMapOvr>
@@ -3360,7 +4049,7 @@
 </p:sld>
 </file>
 
-<file path=ppt/slides/slide4.xml><?xml version="1.0" encoding="utf-8"?>
+<file path=ppt/slides/slide6.xml><?xml version="1.0" encoding="utf-8"?>
 <p:sld xmlns:a="http://schemas.openxmlformats.org/drawingml/2006/main" xmlns:p="http://schemas.openxmlformats.org/presentationml/2006/main" xmlns:r="http://schemas.openxmlformats.org/officeDocument/2006/relationships">
   <p:cSld>
     <p:spTree>
@@ -3385,8 +4074,15 @@
           <a:bodyPr/>
           <a:lstStyle/>
           <a:p>
-            <a:r>
-              <a:t>EDA: Feature Correlation</a:t>
+            <a:pPr>
+              <a:defRPr b="1">
+                <a:solidFill>
+                  <a:srgbClr val="003366"/>
+                </a:solidFill>
+              </a:defRPr>
+            </a:pPr>
+            <a:r>
+              <a:t>Step 2: EDA - Correlation Heatmap</a:t>
             </a:r>
           </a:p>
         </p:txBody>
@@ -3415,162 +4111,30 @@
           </a:prstGeom>
         </p:spPr>
       </p:pic>
-    </p:spTree>
-  </p:cSld>
-  <p:clrMapOvr>
-    <a:masterClrMapping/>
-  </p:clrMapOvr>
-</p:sld>
-</file>
-
-<file path=ppt/slides/slide5.xml><?xml version="1.0" encoding="utf-8"?>
-<p:sld xmlns:a="http://schemas.openxmlformats.org/drawingml/2006/main" xmlns:p="http://schemas.openxmlformats.org/presentationml/2006/main" xmlns:r="http://schemas.openxmlformats.org/officeDocument/2006/relationships">
-  <p:cSld>
-    <p:spTree>
-      <p:nvGrpSpPr>
-        <p:cNvPr id="1" name=""/>
-        <p:cNvGrpSpPr/>
-        <p:nvPr/>
-      </p:nvGrpSpPr>
-      <p:grpSpPr/>
-      <p:sp>
-        <p:nvSpPr>
-          <p:cNvPr id="2" name="Title 1"/>
-          <p:cNvSpPr>
-            <a:spLocks noGrp="1"/>
-          </p:cNvSpPr>
-          <p:nvPr>
-            <p:ph type="title"/>
-          </p:nvPr>
-        </p:nvSpPr>
-        <p:spPr/>
-        <p:txBody>
-          <a:bodyPr/>
-          <a:lstStyle/>
-          <a:p>
-            <a:r>
-              <a:t>Data Preprocessing Pipeline</a:t>
-            </a:r>
-          </a:p>
-        </p:txBody>
-      </p:sp>
-      <p:sp>
-        <p:nvSpPr>
-          <p:cNvPr id="3" name="Content Placeholder 2"/>
-          <p:cNvSpPr>
-            <a:spLocks noGrp="1"/>
-          </p:cNvSpPr>
-          <p:nvPr>
-            <p:ph idx="1"/>
-          </p:nvPr>
-        </p:nvSpPr>
-        <p:spPr/>
-        <p:txBody>
-          <a:bodyPr/>
-          <a:lstStyle/>
-          <a:p>
-            <a:r>
-              <a:t>1. Missing Value Check: None found in dataset.</a:t>
-            </a:r>
-          </a:p>
-          <a:p>
-            <a:r>
-              <a:t>2. Duplicate Removal: Verified no duplicate entries.</a:t>
-            </a:r>
-          </a:p>
-          <a:p>
-            <a:r>
-              <a:t>3. Feature Scaling: StandardScaler applied to normalize data.</a:t>
-            </a:r>
-          </a:p>
-          <a:p>
-            <a:r>
-              <a:t>4. Train-Test Split: 80% Training, 20% Testing.</a:t>
-            </a:r>
-          </a:p>
-          <a:p>
-            <a:r>
-              <a:t>5. PCA: Dimensionality reduction for visualization.</a:t>
-            </a:r>
-          </a:p>
-        </p:txBody>
-      </p:sp>
-    </p:spTree>
-  </p:cSld>
-  <p:clrMapOvr>
-    <a:masterClrMapping/>
-  </p:clrMapOvr>
-</p:sld>
-</file>
-
-<file path=ppt/slides/slide6.xml><?xml version="1.0" encoding="utf-8"?>
-<p:sld xmlns:a="http://schemas.openxmlformats.org/drawingml/2006/main" xmlns:p="http://schemas.openxmlformats.org/presentationml/2006/main" xmlns:r="http://schemas.openxmlformats.org/officeDocument/2006/relationships">
-  <p:cSld>
-    <p:spTree>
-      <p:nvGrpSpPr>
-        <p:cNvPr id="1" name=""/>
-        <p:cNvGrpSpPr/>
-        <p:nvPr/>
-      </p:nvGrpSpPr>
-      <p:grpSpPr/>
-      <p:sp>
-        <p:nvSpPr>
-          <p:cNvPr id="2" name="Title 1"/>
-          <p:cNvSpPr>
-            <a:spLocks noGrp="1"/>
-          </p:cNvSpPr>
-          <p:nvPr>
-            <p:ph type="title"/>
-          </p:nvPr>
-        </p:nvSpPr>
-        <p:spPr/>
-        <p:txBody>
-          <a:bodyPr/>
-          <a:lstStyle/>
-          <a:p>
-            <a:r>
-              <a:t>Model Selection &amp; Training</a:t>
-            </a:r>
-          </a:p>
-        </p:txBody>
-      </p:sp>
-      <p:sp>
-        <p:nvSpPr>
-          <p:cNvPr id="3" name="Content Placeholder 2"/>
-          <p:cNvSpPr>
-            <a:spLocks noGrp="1"/>
-          </p:cNvSpPr>
-          <p:nvPr>
-            <p:ph idx="1"/>
-          </p:nvPr>
-        </p:nvSpPr>
-        <p:spPr/>
-        <p:txBody>
-          <a:bodyPr/>
-          <a:lstStyle/>
-          <a:p>
-            <a:r>
-              <a:t>- Models Evaluated:</a:t>
-            </a:r>
-          </a:p>
-          <a:p>
-            <a:r>
-              <a:t>  1. Logistic Regression (GridSearchCV optimized)</a:t>
-            </a:r>
-          </a:p>
-          <a:p>
-            <a:r>
-              <a:t>  2. Random Forest Classifier</a:t>
-            </a:r>
-          </a:p>
-          <a:p>
-            <a:r>
-              <a:t>  3. Ensemble Voting Classifier (Soft Voting)</a:t>
-            </a:r>
-          </a:p>
-          <a:p>
-            <a:r>
-              <a:t>- Optimization: Used cross-validation to ensure generalization.</a:t>
+      <p:sp>
+        <p:nvSpPr>
+          <p:cNvPr id="4" name="TextBox 3"/>
+          <p:cNvSpPr txBox="1"/>
+          <p:nvPr/>
+        </p:nvSpPr>
+        <p:spPr>
+          <a:xfrm>
+            <a:off x="914400" y="5943600"/>
+            <a:ext cx="7315200" cy="914400"/>
+          </a:xfrm>
+          <a:prstGeom prst="rect">
+            <a:avLst/>
+          </a:prstGeom>
+          <a:noFill/>
+        </p:spPr>
+        <p:txBody>
+          <a:bodyPr wrap="none">
+            <a:spAutoFit/>
+          </a:bodyPr>
+          <a:lstStyle/>
+          <a:p>
+            <a:r>
+              <a:t>Insight: High correlation observed between 'radius', 'perimeter', and 'area'. This suggests multicollinearity which we must handle.</a:t>
             </a:r>
           </a:p>
         </p:txBody>
@@ -3608,49 +4172,67 @@
           <a:bodyPr/>
           <a:lstStyle/>
           <a:p>
-            <a:r>
-              <a:t>Model Performance (Logistic Regression)</a:t>
-            </a:r>
-          </a:p>
-        </p:txBody>
-      </p:sp>
-      <p:sp>
-        <p:nvSpPr>
-          <p:cNvPr id="3" name="Content Placeholder 2"/>
-          <p:cNvSpPr>
-            <a:spLocks noGrp="1"/>
-          </p:cNvSpPr>
-          <p:nvPr>
-            <p:ph idx="1"/>
-          </p:nvPr>
-        </p:nvSpPr>
-        <p:spPr/>
-        <p:txBody>
-          <a:bodyPr/>
-          <a:lstStyle/>
-          <a:p>
-            <a:r>
-              <a:t>- Accuracy: 97.4%</a:t>
-            </a:r>
-          </a:p>
-          <a:p>
-            <a:r>
-              <a:t>- F1-Score: 0.98</a:t>
-            </a:r>
-          </a:p>
-          <a:p>
-            <a:r>
-              <a:t>- Precision: 0.97</a:t>
-            </a:r>
-          </a:p>
-          <a:p>
-            <a:r>
-              <a:t>- Recall: 0.99</a:t>
-            </a:r>
-          </a:p>
-          <a:p>
-            <a:r>
-              <a:t>- The model shows high reliability for clinical assistance.</a:t>
+            <a:pPr>
+              <a:defRPr b="1">
+                <a:solidFill>
+                  <a:srgbClr val="003366"/>
+                </a:solidFill>
+              </a:defRPr>
+            </a:pPr>
+            <a:r>
+              <a:t>Step 2: EDA - Outlier Detection</a:t>
+            </a:r>
+          </a:p>
+        </p:txBody>
+      </p:sp>
+      <p:pic>
+        <p:nvPicPr>
+          <p:cNvPr id="3" name="Picture 2" descr="boxplot.png"/>
+          <p:cNvPicPr>
+            <a:picLocks noChangeAspect="1"/>
+          </p:cNvPicPr>
+          <p:nvPr/>
+        </p:nvPicPr>
+        <p:blipFill>
+          <a:blip r:embed="rId2"/>
+          <a:stretch>
+            <a:fillRect/>
+          </a:stretch>
+        </p:blipFill>
+        <p:spPr>
+          <a:xfrm>
+            <a:off x="914400" y="1371600"/>
+            <a:ext cx="7620000" cy="4572000"/>
+          </a:xfrm>
+          <a:prstGeom prst="rect">
+            <a:avLst/>
+          </a:prstGeom>
+        </p:spPr>
+      </p:pic>
+      <p:sp>
+        <p:nvSpPr>
+          <p:cNvPr id="4" name="TextBox 3"/>
+          <p:cNvSpPr txBox="1"/>
+          <p:nvPr/>
+        </p:nvSpPr>
+        <p:spPr>
+          <a:xfrm>
+            <a:off x="914400" y="5943600"/>
+            <a:ext cx="7315200" cy="914400"/>
+          </a:xfrm>
+          <a:prstGeom prst="rect">
+            <a:avLst/>
+          </a:prstGeom>
+          <a:noFill/>
+        </p:spPr>
+        <p:txBody>
+          <a:bodyPr wrap="none">
+            <a:spAutoFit/>
+          </a:bodyPr>
+          <a:lstStyle/>
+          <a:p>
+            <a:r>
+              <a:t>Observation: Presence of outliers in several features. Robust models or proper scaling are necessary.</a:t>
             </a:r>
           </a:p>
         </p:txBody>
@@ -3688,15 +4270,22 @@
           <a:bodyPr/>
           <a:lstStyle/>
           <a:p>
-            <a:r>
-              <a:t>Evaluation: Confusion Matrix</a:t>
+            <a:pPr>
+              <a:defRPr b="1">
+                <a:solidFill>
+                  <a:srgbClr val="003366"/>
+                </a:solidFill>
+              </a:defRPr>
+            </a:pPr>
+            <a:r>
+              <a:t>Step 2: EDA - PCA Visualization</a:t>
             </a:r>
           </a:p>
         </p:txBody>
       </p:sp>
       <p:pic>
         <p:nvPicPr>
-          <p:cNvPr id="3" name="Picture 2" descr="cm_Logistic_Regression.png"/>
+          <p:cNvPr id="3" name="Picture 2" descr="pca_plot.png"/>
           <p:cNvPicPr>
             <a:picLocks noChangeAspect="1"/>
           </p:cNvPicPr>
@@ -3710,14 +4299,42 @@
         </p:blipFill>
         <p:spPr>
           <a:xfrm>
-            <a:off x="1371600" y="1371600"/>
-            <a:ext cx="6858000" cy="4572000"/>
+            <a:off x="914400" y="1371600"/>
+            <a:ext cx="6096000" cy="4572000"/>
           </a:xfrm>
           <a:prstGeom prst="rect">
             <a:avLst/>
           </a:prstGeom>
         </p:spPr>
       </p:pic>
+      <p:sp>
+        <p:nvSpPr>
+          <p:cNvPr id="4" name="TextBox 3"/>
+          <p:cNvSpPr txBox="1"/>
+          <p:nvPr/>
+        </p:nvSpPr>
+        <p:spPr>
+          <a:xfrm>
+            <a:off x="914400" y="5943600"/>
+            <a:ext cx="7315200" cy="914400"/>
+          </a:xfrm>
+          <a:prstGeom prst="rect">
+            <a:avLst/>
+          </a:prstGeom>
+          <a:noFill/>
+        </p:spPr>
+        <p:txBody>
+          <a:bodyPr wrap="none">
+            <a:spAutoFit/>
+          </a:bodyPr>
+          <a:lstStyle/>
+          <a:p>
+            <a:r>
+              <a:t>Result: Clear separation between Malignant and Benign clusters in 2D space using PCA.</a:t>
+            </a:r>
+          </a:p>
+        </p:txBody>
+      </p:sp>
     </p:spTree>
   </p:cSld>
   <p:clrMapOvr>
@@ -3751,8 +4368,15 @@
           <a:bodyPr/>
           <a:lstStyle/>
           <a:p>
-            <a:r>
-              <a:t>Streamlit Web Application</a:t>
+            <a:pPr>
+              <a:defRPr b="1">
+                <a:solidFill>
+                  <a:srgbClr val="003366"/>
+                </a:solidFill>
+              </a:defRPr>
+            </a:pPr>
+            <a:r>
+              <a:t>Step 3: Data Preprocessing Pipeline</a:t>
             </a:r>
           </a:p>
         </p:txBody>
@@ -3773,27 +4397,31 @@
           <a:lstStyle/>
           <a:p>
             <a:r>
-              <a:t>- Features:</a:t>
-            </a:r>
-          </a:p>
-          <a:p>
-            <a:r>
-              <a:t>  - Interactive sliders for patient parameters.</a:t>
-            </a:r>
-          </a:p>
-          <a:p>
-            <a:r>
-              <a:t>  - Real-time prediction with confidence scores.</a:t>
-            </a:r>
-          </a:p>
-          <a:p>
-            <a:r>
-              <a:t>  - Dynamic visualization of model metrics.</a:t>
-            </a:r>
-          </a:p>
-          <a:p>
-            <a:r>
-              <a:t>  - Professional UI using custom CSS.</a:t>
+              <a:t>1. Data Cleaning: No missing values detected.</a:t>
+            </a:r>
+          </a:p>
+          <a:p>
+            <a:pPr>
+              <a:defRPr sz="1800"/>
+            </a:pPr>
+            <a:r>
+              <a:t>2. Feature Engineering: Separation of 30 clinical features.</a:t>
+            </a:r>
+          </a:p>
+          <a:p>
+            <a:pPr>
+              <a:defRPr sz="1800"/>
+            </a:pPr>
+            <a:r>
+              <a:t>3. Data Scaling: Used StandardScaler (Z-score normalization).</a:t>
+            </a:r>
+          </a:p>
+          <a:p>
+            <a:pPr>
+              <a:defRPr sz="1800"/>
+            </a:pPr>
+            <a:r>
+              <a:t>4. Data Splitting: 80/20 train-test split with stratification.</a:t>
             </a:r>
           </a:p>
         </p:txBody>

</xml_diff>